<commit_message>
Test fix: correct font sizes and row heights on slide 2 (L2 Fullfilment only)
- Table cells: explicit 10.5pt instead of inherited
- Reportes/Pares: 9pt with separate bold label + non-bold value runs
- Dimensionamiento: 12pt with separate bold label + non-bold value runs
- Table row heights locked to template values after populating cells

https://claude.ai/code/session_01HJMMdgWhC2zXRqBG1eG17e
</commit_message>
<xml_diff>
--- a/Estrategia y Transformacion/Descripciones de Puestos/Gerente Sr Fullfilment/ET - L2 Gerente Sr Fullfilment.pptx
+++ b/Estrategia y Transformacion/Descripciones de Puestos/Gerente Sr Fullfilment/ET - L2 Gerente Sr Fullfilment.pptx
@@ -4487,7 +4487,7 @@
               <a:defRPr/>
             </a:pPr>
             <a:r>
-              <a:rPr kumimoji="0" lang="es-MX" sz="1200" b="1" i="0" u="none" strike="noStrike" kern="1200" cap="none" spc="0" normalizeH="0" baseline="0" noProof="0" dirty="0">
+              <a:rPr kumimoji="0" lang="es-MX" sz="1100" b="0" i="0" u="none" strike="noStrike" kern="1200" cap="none" spc="0" normalizeH="0" baseline="0" noProof="0" dirty="0">
                 <a:ln>
                   <a:noFill/>
                 </a:ln>
@@ -4781,7 +4781,7 @@
               <a:defRPr/>
             </a:pPr>
             <a:r>
-              <a:rPr kumimoji="0" lang="es-MX" sz="800" b="0" i="0" u="none" strike="noStrike" kern="1200" cap="none" spc="0" normalizeH="0" baseline="0" noProof="0" dirty="0">
+              <a:rPr kumimoji="0" lang="es-MX" sz="900" b="0" i="0" u="none" strike="noStrike" kern="1200" cap="none" spc="0" normalizeH="0" baseline="0" noProof="0" dirty="0">
                 <a:ln>
                   <a:noFill/>
                 </a:ln>
@@ -4795,7 +4795,7 @@
                 <a:ea typeface="ＭＳ Ｐゴシック" charset="0"/>
                 <a:cs typeface="Arial"/>
               </a:rPr>
-              <a:t>Definir y liderar la estrategia integral de Fulfillment, incluyendo los servicios digitales, e-commerce y pagos, asegurando su alineación con los objetivos del negocio, el modelo comercial y la experiencia del cliente.</a:t>
+              <a:t>Definir y liderar la estrategia integral de Fulfillment, incluyendo servicios digitales, e-commerce y pagos, asegurando alineación con los objetivos del negocio, el modelo comercial y la experiencia del cliente.</a:t>
             </a:r>
           </a:p>
           <a:p>
@@ -4819,7 +4819,7 @@
               <a:defRPr/>
             </a:pPr>
             <a:r>
-              <a:rPr kumimoji="0" lang="es-MX" sz="800" b="0" i="0" u="none" strike="noStrike" kern="1200" cap="none" spc="0" normalizeH="0" baseline="0" noProof="0" dirty="0">
+              <a:rPr kumimoji="0" lang="es-MX" sz="900" b="0" i="0" u="none" strike="noStrike" kern="1200" cap="none" spc="0" normalizeH="0" baseline="0" noProof="0" dirty="0">
                 <a:ln>
                   <a:noFill/>
                 </a:ln>
@@ -4857,7 +4857,7 @@
               <a:defRPr/>
             </a:pPr>
             <a:r>
-              <a:rPr kumimoji="0" lang="es-MX" sz="800" b="0" i="0" u="none" strike="noStrike" kern="1200" cap="none" spc="0" normalizeH="0" baseline="0" noProof="0" dirty="0">
+              <a:rPr kumimoji="0" lang="es-MX" sz="900" b="0" i="0" u="none" strike="noStrike" kern="1200" cap="none" spc="0" normalizeH="0" baseline="0" noProof="0" dirty="0">
                 <a:ln>
                   <a:noFill/>
                 </a:ln>
@@ -4871,7 +4871,7 @@
                 <a:ea typeface="ＭＳ Ｐゴシック" charset="0"/>
                 <a:cs typeface="Arial"/>
               </a:rPr>
-              <a:t>Orquestar la ejecución end-to-end del modelo de Fulfillment, asegurando la integración efectiva entre áreas comerciales, marketing, operaciones, TI, producto y diseño organizacional.</a:t>
+              <a:t>Orquestar la ejecución end-to-end del modelo de Fulfillment, asegurando integración efectiva entre áreas comerciales, marketing, operaciones, TI, producto y diseño organizacional.</a:t>
             </a:r>
           </a:p>
           <a:p>
@@ -4895,7 +4895,7 @@
               <a:defRPr/>
             </a:pPr>
             <a:r>
-              <a:rPr kumimoji="0" lang="es-MX" sz="800" b="0" i="0" u="none" strike="noStrike" kern="1200" cap="none" spc="0" normalizeH="0" baseline="0" noProof="0" dirty="0">
+              <a:rPr kumimoji="0" lang="es-MX" sz="900" b="0" i="0" u="none" strike="noStrike" kern="1200" cap="none" spc="0" normalizeH="0" baseline="0" noProof="0" dirty="0">
                 <a:ln>
                   <a:noFill/>
                 </a:ln>
@@ -4933,7 +4933,7 @@
               <a:defRPr/>
             </a:pPr>
             <a:r>
-              <a:rPr kumimoji="0" lang="es-MX" sz="800" b="0" i="0" u="none" strike="noStrike" kern="1200" cap="none" spc="0" normalizeH="0" baseline="0" noProof="0" dirty="0">
+              <a:rPr kumimoji="0" lang="es-MX" sz="900" b="0" i="0" u="none" strike="noStrike" kern="1200" cap="none" spc="0" normalizeH="0" baseline="0" noProof="0" dirty="0">
                 <a:ln>
                   <a:noFill/>
                 </a:ln>
@@ -4971,7 +4971,7 @@
               <a:defRPr/>
             </a:pPr>
             <a:r>
-              <a:rPr kumimoji="0" lang="es-MX" sz="800" b="0" i="0" u="none" strike="noStrike" kern="1200" cap="none" spc="0" normalizeH="0" baseline="0" noProof="0" dirty="0">
+              <a:rPr kumimoji="0" lang="es-MX" sz="900" b="0" i="0" u="none" strike="noStrike" kern="1200" cap="none" spc="0" normalizeH="0" baseline="0" noProof="0" dirty="0">
                 <a:ln>
                   <a:noFill/>
                 </a:ln>
@@ -5009,7 +5009,7 @@
               <a:defRPr/>
             </a:pPr>
             <a:r>
-              <a:rPr kumimoji="0" lang="es-MX" sz="800" b="0" i="0" u="none" strike="noStrike" kern="1200" cap="none" spc="0" normalizeH="0" baseline="0" noProof="0" dirty="0">
+              <a:rPr kumimoji="0" lang="es-MX" sz="900" b="0" i="0" u="none" strike="noStrike" kern="1200" cap="none" spc="0" normalizeH="0" baseline="0" noProof="0" dirty="0">
                 <a:ln>
                   <a:noFill/>
                 </a:ln>
@@ -5047,7 +5047,7 @@
               <a:defRPr/>
             </a:pPr>
             <a:r>
-              <a:rPr kumimoji="0" lang="es-MX" sz="800" b="0" i="0" u="none" strike="noStrike" kern="1200" cap="none" spc="0" normalizeH="0" baseline="0" noProof="0" dirty="0">
+              <a:rPr kumimoji="0" lang="es-MX" sz="900" b="0" i="0" u="none" strike="noStrike" kern="1200" cap="none" spc="0" normalizeH="0" baseline="0" noProof="0" dirty="0">
                 <a:ln>
                   <a:noFill/>
                 </a:ln>
@@ -5061,7 +5061,7 @@
                 <a:ea typeface="ＭＳ Ｐゴシック" charset="0"/>
                 <a:cs typeface="Arial"/>
               </a:rPr>
-              <a:t>Desarrollar y coordinar a los equipos a su cargo, fortaleciendo las capacidades organizacionales necesarias para la evolución y sostenibilidad del modelo Fulfillment.</a:t>
+              <a:t>Desarrollar y coordinar a los equipos a su cargo, fortaleciendo las capacidades organizacionales para la evolución y sostenibilidad del modelo Fulfillment.</a:t>
             </a:r>
           </a:p>
         </p:txBody>
@@ -5341,7 +5341,7 @@
               <a:defRPr/>
             </a:pPr>
             <a:r>
-              <a:rPr lang="es-MX" sz="1000" dirty="0">
+              <a:rPr lang="es-MX" sz="900" dirty="0" b="0">
                 <a:solidFill>
                   <a:prstClr val="black"/>
                 </a:solidFill>
@@ -5385,7 +5385,7 @@
               <a:defRPr/>
             </a:pPr>
             <a:r>
-              <a:rPr lang="es-MX" sz="1000" dirty="0">
+              <a:rPr lang="es-MX" sz="900" dirty="0" b="0">
                 <a:solidFill>
                   <a:prstClr val="black"/>
                 </a:solidFill>
@@ -5429,7 +5429,7 @@
               <a:defRPr/>
             </a:pPr>
             <a:r>
-              <a:rPr lang="es-MX" sz="1000" dirty="0">
+              <a:rPr lang="es-MX" sz="900" dirty="0" b="0">
                 <a:solidFill>
                   <a:prstClr val="black"/>
                 </a:solidFill>
@@ -5473,7 +5473,7 @@
               <a:defRPr/>
             </a:pPr>
             <a:r>
-              <a:rPr lang="es-MX" sz="1000" dirty="0">
+              <a:rPr lang="es-MX" sz="900" dirty="0" b="0">
                 <a:solidFill>
                   <a:prstClr val="black"/>
                 </a:solidFill>
@@ -5517,7 +5517,7 @@
               <a:defRPr/>
             </a:pPr>
             <a:r>
-              <a:rPr lang="es-MX" sz="1000" dirty="0">
+              <a:rPr lang="es-MX" sz="900" dirty="0" b="0">
                 <a:solidFill>
                   <a:prstClr val="black"/>
                 </a:solidFill>
@@ -5817,13 +5817,13 @@
               <a:defRPr/>
             </a:pPr>
             <a:r>
-              <a:rPr lang="es-MX" sz="1000" dirty="0">
+              <a:rPr lang="es-MX" sz="900" dirty="0" b="0">
                 <a:solidFill>
                   <a:prstClr val="black"/>
                 </a:solidFill>
                 <a:latin typeface="Calibri Light" panose="020F0302020204030204"/>
               </a:rPr>
-              <a:t>Lograr una integración ágil y consistente entre áreas comerciales, marketing, operaciones, TI y producto, evitando silos y fricciones en la ejecución sin dependencia jerárquica directa.</a:t>
+              <a:t>Lograr integración ágil y consistente entre áreas comerciales, marketing, operaciones, TI y producto, evitando silos y fricciones en la ejecución sin dependencia jerárquica directa.</a:t>
             </a:r>
             <a:endParaRPr kumimoji="0" lang="es-MX" sz="1000" b="0" i="0" u="none" strike="noStrike" kern="1200" cap="none" spc="0" normalizeH="0" baseline="0" noProof="0" dirty="0">
               <a:ln>
@@ -5861,7 +5861,7 @@
               <a:defRPr/>
             </a:pPr>
             <a:r>
-              <a:rPr lang="es-MX" sz="1000" dirty="0">
+              <a:rPr lang="es-MX" sz="900" dirty="0" b="0">
                 <a:solidFill>
                   <a:prstClr val="black"/>
                 </a:solidFill>
@@ -5905,13 +5905,13 @@
               <a:defRPr/>
             </a:pPr>
             <a:r>
-              <a:rPr lang="es-MX" sz="1000" dirty="0">
+              <a:rPr lang="es-MX" sz="900" dirty="0" b="0">
                 <a:solidFill>
                   <a:prstClr val="black"/>
                 </a:solidFill>
                 <a:latin typeface="Calibri Light" panose="020F0302020204030204"/>
               </a:rPr>
-              <a:t>Asegurar que la estrategia, los roadmaps y las decisiones del portafolio se traduzcan en resultados concretos a nivel operativo, comercial y de experiencia del cliente.</a:t>
+              <a:t>Asegurar que la estrategia, roadmaps y decisiones del portafolio se traduzcan en resultados concretos a nivel operativo, comercial y de experiencia del cliente.</a:t>
             </a:r>
             <a:endParaRPr kumimoji="0" lang="es-MX" sz="1000" b="0" i="0" u="none" strike="noStrike" kern="1200" cap="none" spc="0" normalizeH="0" baseline="0" noProof="0" dirty="0">
               <a:ln>
@@ -5949,7 +5949,7 @@
               <a:defRPr/>
             </a:pPr>
             <a:r>
-              <a:rPr lang="es-MX" sz="1000" dirty="0">
+              <a:rPr lang="es-MX" sz="900" dirty="0" b="0">
                 <a:solidFill>
                   <a:prstClr val="black"/>
                 </a:solidFill>
@@ -5993,13 +5993,13 @@
               <a:defRPr/>
             </a:pPr>
             <a:r>
-              <a:rPr lang="es-MX" sz="1000" dirty="0">
+              <a:rPr lang="es-MX" sz="900" dirty="0" b="0">
                 <a:solidFill>
                   <a:prstClr val="black"/>
                 </a:solidFill>
                 <a:latin typeface="Calibri Light" panose="020F0302020204030204"/>
               </a:rPr>
-              <a:t>Impulsar la correcta implementación de los servicios de Fulfillment en tienda, minimizando fricciones operativas y garantizando una experiencia consistente para el cliente.</a:t>
+              <a:t>Impulsar la correcta implementación de los servicios en tienda, minimizando fricciones operativas y garantizando una experiencia consistente para el cliente.</a:t>
             </a:r>
             <a:endParaRPr kumimoji="0" lang="es-MX" sz="1000" b="0" i="0" u="none" strike="noStrike" kern="1200" cap="none" spc="0" normalizeH="0" baseline="0" noProof="0" dirty="0">
               <a:ln>
@@ -9548,7 +9548,24 @@
                 <a:ea typeface="ＭＳ Ｐゴシック" charset="0"/>
                 <a:cs typeface="Arial"/>
               </a:rPr>
-              <a:t>Negocios: OXXO México</a:t>
+              <a:t>Negocios: </a:t>
+            </a:r>
+            <a:r>
+              <a:rPr kumimoji="0" lang="es-MX" sz="1200" b="0" i="0" u="none" strike="noStrike" kern="1200" cap="none" spc="0" normalizeH="0" baseline="0" noProof="0" dirty="0">
+                <a:ln>
+                  <a:noFill/>
+                </a:ln>
+                <a:solidFill>
+                  <a:prstClr val="black"/>
+                </a:solidFill>
+                <a:effectLst/>
+                <a:uLnTx/>
+                <a:uFillTx/>
+                <a:latin typeface="Calibri Light" panose="020F0302020204030204"/>
+                <a:ea typeface="ＭＳ Ｐゴシック" charset="0"/>
+                <a:cs typeface="Arial"/>
+              </a:rPr>
+              <a:t>OXXO México</a:t>
             </a:r>
             <a:endParaRPr kumimoji="0" lang="es-MX" sz="1200" b="0" i="0" u="none" strike="noStrike" kern="1200" cap="none" spc="0" normalizeH="0" baseline="0" noProof="0" dirty="0">
               <a:ln>
@@ -9635,7 +9652,24 @@
                 <a:ea typeface="ＭＳ Ｐゴシック" charset="0"/>
                 <a:cs typeface="Arial"/>
               </a:rPr>
-              <a:t>Alcance Geográfico: Nacional</a:t>
+              <a:t>Alcance Geográfico: </a:t>
+            </a:r>
+            <a:r>
+              <a:rPr kumimoji="0" lang="es-MX" sz="1200" b="0" i="0" u="none" strike="noStrike" kern="1200" cap="none" spc="0" normalizeH="0" baseline="0" noProof="0" dirty="0">
+                <a:ln>
+                  <a:noFill/>
+                </a:ln>
+                <a:solidFill>
+                  <a:prstClr val="black"/>
+                </a:solidFill>
+                <a:effectLst/>
+                <a:uLnTx/>
+                <a:uFillTx/>
+                <a:latin typeface="Calibri Light" panose="020F0302020204030204"/>
+                <a:ea typeface="ＭＳ Ｐゴシック" charset="0"/>
+                <a:cs typeface="Arial"/>
+              </a:rPr>
+              <a:t>Nacional</a:t>
             </a:r>
             <a:endParaRPr kumimoji="0" lang="es-MX" sz="1200" b="0" i="0" u="none" strike="noStrike" kern="1200" cap="none" spc="0" normalizeH="0" baseline="0" noProof="0" dirty="0">
               <a:ln>
@@ -9722,7 +9756,24 @@
                 <a:ea typeface="ＭＳ Ｐゴシック" charset="0"/>
                 <a:cs typeface="Arial"/>
               </a:rPr>
-              <a:t>Tramo de supervisión: 5 reportes directos</a:t>
+              <a:t>Tramo de supervisión: </a:t>
+            </a:r>
+            <a:r>
+              <a:rPr kumimoji="0" lang="es-MX" sz="1200" b="0" i="0" u="none" strike="noStrike" kern="1200" cap="none" spc="0" normalizeH="0" baseline="0" noProof="0" dirty="0">
+                <a:ln>
+                  <a:noFill/>
+                </a:ln>
+                <a:solidFill>
+                  <a:prstClr val="black"/>
+                </a:solidFill>
+                <a:effectLst/>
+                <a:uLnTx/>
+                <a:uFillTx/>
+                <a:latin typeface="Calibri Light" panose="020F0302020204030204"/>
+                <a:ea typeface="ＭＳ Ｐゴシック" charset="0"/>
+                <a:cs typeface="Arial"/>
+              </a:rPr>
+              <a:t>5 reportes directos</a:t>
             </a:r>
           </a:p>
           <a:p>
@@ -10074,7 +10125,7 @@
               <a:defRPr/>
             </a:pPr>
             <a:r>
-              <a:rPr kumimoji="0" lang="es-MX" sz="1200" b="1" i="0" u="none" strike="noStrike" kern="1200" cap="none" spc="0" normalizeH="0" baseline="0" noProof="0" dirty="0">
+              <a:rPr kumimoji="0" lang="es-MX" sz="900" b="1" i="0" u="none" strike="noStrike" kern="1200" cap="none" spc="0" normalizeH="0" baseline="0" noProof="0" dirty="0">
                 <a:ln>
                   <a:noFill/>
                 </a:ln>
@@ -10088,7 +10139,24 @@
                 <a:ea typeface="ＭＳ Ｐゴシック" charset="0"/>
                 <a:cs typeface="Arial"/>
               </a:rPr>
-              <a:t>Reportes Directos: Coordinador Product Owner Servicios (Paulina Salinas), Responsable MKT Adquisición Cliente (Cesar Garza), Coordinador Op Fullfillment (Antonio Mora), Responsable Op Dis Fullfillment (Alberto Valdez), Gerente Área Comercial Fullfillment (Kenya Vazquez)</a:t>
+              <a:t>Reportes Directos: </a:t>
+            </a:r>
+            <a:r>
+              <a:rPr kumimoji="0" lang="es-MX" sz="900" b="0" i="0" u="none" strike="noStrike" kern="1200" cap="none" spc="0" normalizeH="0" baseline="0" noProof="0" dirty="0">
+                <a:ln>
+                  <a:noFill/>
+                </a:ln>
+                <a:solidFill>
+                  <a:prstClr val="black"/>
+                </a:solidFill>
+                <a:effectLst/>
+                <a:uLnTx/>
+                <a:uFillTx/>
+                <a:latin typeface="Calibri Light" panose="020F0302020204030204"/>
+                <a:ea typeface="ＭＳ Ｐゴシック" charset="0"/>
+                <a:cs typeface="Arial"/>
+              </a:rPr>
+              <a:t>Coordinador Product Owner Servicios (Paulina Salinas), Responsable MKT Adquisición Cliente (Cesar Garza), Coordinador Op Fullfillment (Antonio Mora), Responsable Op Dis Fullfillment (Alberto Valdez), Gerente Área Comercial Fullfillment (Kenya Vazquez)</a:t>
             </a:r>
             <a:endParaRPr kumimoji="0" lang="es-MX" sz="1200" b="0" i="0" u="none" strike="noStrike" kern="1200" cap="none" spc="0" normalizeH="0" baseline="0" noProof="0" dirty="0">
               <a:ln>
@@ -10126,7 +10194,7 @@
               <a:defRPr/>
             </a:pPr>
             <a:r>
-              <a:rPr kumimoji="0" lang="es-MX" sz="1200" b="1" i="0" u="none" strike="noStrike" kern="1200" cap="none" spc="0" normalizeH="0" baseline="0" noProof="0" dirty="0">
+              <a:rPr kumimoji="0" lang="es-MX" sz="900" b="1" i="0" u="none" strike="noStrike" kern="1200" cap="none" spc="0" normalizeH="0" baseline="0" noProof="0" dirty="0">
                 <a:ln>
                   <a:noFill/>
                 </a:ln>
@@ -10140,7 +10208,24 @@
                 <a:ea typeface="ＭＳ Ｐゴシック" charset="0"/>
                 <a:cs typeface="Arial"/>
               </a:rPr>
-              <a:t>Pares: Gerente OXXO Cel, Gerente Sr Comercial Servicios Financieros, Gerente Sr Comercial Comercio Electrónico</a:t>
+              <a:t>Pares: </a:t>
+            </a:r>
+            <a:r>
+              <a:rPr kumimoji="0" lang="es-MX" sz="900" b="0" i="0" u="none" strike="noStrike" kern="1200" cap="none" spc="0" normalizeH="0" baseline="0" noProof="0" dirty="0">
+                <a:ln>
+                  <a:noFill/>
+                </a:ln>
+                <a:solidFill>
+                  <a:prstClr val="black"/>
+                </a:solidFill>
+                <a:effectLst/>
+                <a:uLnTx/>
+                <a:uFillTx/>
+                <a:latin typeface="Calibri Light" panose="020F0302020204030204"/>
+                <a:ea typeface="ＭＳ Ｐゴシック" charset="0"/>
+                <a:cs typeface="Arial"/>
+              </a:rPr>
+              <a:t>Gerente OXXO Cel, Gerente Sr Comercial Servicios Financieros, Gerente Sr Comercial Comercio Electrónico</a:t>
             </a:r>
             <a:endParaRPr kumimoji="0" lang="es-MX" sz="1200" b="0" i="0" u="none" strike="noStrike" kern="1200" cap="none" spc="0" normalizeH="0" baseline="0" noProof="0" dirty="0">
               <a:ln>
@@ -11885,6 +11970,7 @@
                         <a:cs typeface="Arial" panose="020B0604020202020204" pitchFamily="34" charset="0"/>
                       </a:endParaRPr>
                       <a:r>
+                        <a:rPr sz="1050" b="0"/>
                         <a:t>Director Estrategia y Transformación</a:t>
                       </a:r>
                     </a:p>
@@ -11948,7 +12034,8 @@
                         <a:cs typeface="Arial" panose="020B0604020202020204" pitchFamily="34" charset="0"/>
                       </a:endParaRPr>
                       <a:r>
-                        <a:t>Alineación estratégica y reporte de resultados del área</a:t>
+                        <a:rPr sz="1050" b="0"/>
+                        <a:t>Alineación estratégica y reporte de resultados</a:t>
                       </a:r>
                     </a:p>
                   </a:txBody>
@@ -12025,6 +12112,7 @@
                         <a:cs typeface="Arial" panose="020B0604020202020204" pitchFamily="34" charset="0"/>
                       </a:endParaRPr>
                       <a:r>
+                        <a:rPr sz="1050" b="0"/>
                         <a:t>Mensual</a:t>
                       </a:r>
                     </a:p>
@@ -12082,6 +12170,7 @@
                     <a:p>
                       <a:endParaRPr lang="es-MX"/>
                       <a:r>
+                        <a:rPr sz="900" b="1"/>
                         <a:t/>
                       </a:r>
                     </a:p>
@@ -12108,6 +12197,7 @@
                         <a:cs typeface="Arial" panose="020B0604020202020204" pitchFamily="34" charset="0"/>
                       </a:endParaRPr>
                       <a:r>
+                        <a:rPr sz="1050" b="0"/>
                         <a:t>Gerente OXXO Cel</a:t>
                       </a:r>
                     </a:p>
@@ -12174,7 +12264,8 @@
                         <a:cs typeface="Arial" panose="020B0604020202020204" pitchFamily="34" charset="0"/>
                       </a:endParaRPr>
                       <a:r>
-                        <a:t>Coordinación de estrategia de servicios digitales y cliente</a:t>
+                        <a:rPr sz="1050" b="0"/>
+                        <a:t>Coordinación de servicios digitales y experiencia del cliente</a:t>
                       </a:r>
                     </a:p>
                   </a:txBody>
@@ -12251,6 +12342,7 @@
                         <a:cs typeface="Arial" panose="020B0604020202020204" pitchFamily="34" charset="0"/>
                       </a:endParaRPr>
                       <a:r>
+                        <a:rPr sz="1050" b="0"/>
                         <a:t>Semanal</a:t>
                       </a:r>
                     </a:p>
@@ -12308,6 +12400,7 @@
                     <a:p>
                       <a:endParaRPr lang="es-MX"/>
                       <a:r>
+                        <a:rPr sz="900" b="1"/>
                         <a:t/>
                       </a:r>
                     </a:p>
@@ -12334,7 +12427,8 @@
                         <a:cs typeface="Arial" panose="020B0604020202020204" pitchFamily="34" charset="0"/>
                       </a:endParaRPr>
                       <a:r>
-                        <a:t>Gerente Sr Comercial Servicios Financieros</a:t>
+                        <a:rPr sz="1050" b="0"/>
+                        <a:t>Gte Sr Comercial Servicios Financieros</a:t>
                       </a:r>
                     </a:p>
                   </a:txBody>
@@ -12411,7 +12505,8 @@
                         <a:cs typeface="Arial" panose="020B0604020202020204" pitchFamily="34" charset="0"/>
                       </a:endParaRPr>
                       <a:r>
-                        <a:t>Integración de capacidades financieras y de pago en el modelo</a:t>
+                        <a:rPr sz="1050" b="0"/>
+                        <a:t>Integración de capacidades financieras y de pago</a:t>
                       </a:r>
                     </a:p>
                   </a:txBody>
@@ -12488,6 +12583,7 @@
                         <a:cs typeface="Arial" panose="020B0604020202020204" pitchFamily="34" charset="0"/>
                       </a:endParaRPr>
                       <a:r>
+                        <a:rPr sz="1050" b="0"/>
                         <a:t>Quincenal</a:t>
                       </a:r>
                     </a:p>
@@ -12545,6 +12641,7 @@
                     <a:p>
                       <a:endParaRPr lang="es-MX"/>
                       <a:r>
+                        <a:rPr sz="900" b="1"/>
                         <a:t/>
                       </a:r>
                     </a:p>
@@ -12571,6 +12668,7 @@
                         <a:cs typeface="Arial" panose="020B0604020202020204" pitchFamily="34" charset="0"/>
                       </a:endParaRPr>
                       <a:r>
+                        <a:rPr sz="1050" b="0"/>
                         <a:t>Áreas Comerciales y Operaciones</a:t>
                       </a:r>
                     </a:p>
@@ -12648,7 +12746,8 @@
                         <a:cs typeface="Arial" panose="020B0604020202020204" pitchFamily="34" charset="0"/>
                       </a:endParaRPr>
                       <a:r>
-                        <a:t>Ejecución y despliegue de servicios de Fulfillment en tienda</a:t>
+                        <a:rPr sz="1050" b="0"/>
+                        <a:t>Ejecución y despliegue de servicios en tienda</a:t>
                       </a:r>
                     </a:p>
                   </a:txBody>
@@ -12725,6 +12824,7 @@
                         <a:cs typeface="Arial" panose="020B0604020202020204" pitchFamily="34" charset="0"/>
                       </a:endParaRPr>
                       <a:r>
+                        <a:rPr sz="1050" b="0"/>
                         <a:t>Semanal</a:t>
                       </a:r>
                     </a:p>
@@ -12782,6 +12882,7 @@
                     <a:p>
                       <a:endParaRPr lang="es-MX"/>
                       <a:r>
+                        <a:rPr sz="900" b="1"/>
                         <a:t/>
                       </a:r>
                     </a:p>
@@ -12808,6 +12909,7 @@
                         <a:cs typeface="Arial" panose="020B0604020202020204" pitchFamily="34" charset="0"/>
                       </a:endParaRPr>
                       <a:r>
+                        <a:rPr sz="1050" b="0"/>
                         <a:t>TI</a:t>
                       </a:r>
                     </a:p>
@@ -12885,6 +12987,7 @@
                         <a:cs typeface="Arial" panose="020B0604020202020204" pitchFamily="34" charset="0"/>
                       </a:endParaRPr>
                       <a:r>
+                        <a:rPr sz="1050" b="0"/>
                         <a:t>Integración tecnológica y entrega de soluciones digitales</a:t>
                       </a:r>
                     </a:p>
@@ -12962,6 +13065,7 @@
                         <a:cs typeface="Arial" panose="020B0604020202020204" pitchFamily="34" charset="0"/>
                       </a:endParaRPr>
                       <a:r>
+                        <a:rPr sz="1050" b="0"/>
                         <a:t>Semanal</a:t>
                       </a:r>
                     </a:p>

</xml_diff>